<commit_message>
Reescreve as respostas do slide de conclusão
As respostas eram fragmentos de estatística em vez de respostas. 'O dobro do peso
da segunda variável' fala da mecânica do modelo, não da alfabetização. 'Quinto
mais crítico' e 'p.p.' são termos que um gestor não usa. E a última nem respondia
a pergunta: dava um número nacional quando o que se perguntava era como prever
quem fica para trás.

Cada resposta passa a ser uma frase completa, que a pessoa consegue repetir depois
de ler uma vez. A primeira responde o que importa no mundo, onde a criança estuda;
a segunda, o que o modelo de fato usa. Antes as duas diziam quase a mesma coisa.

A concentração regional passa a aparecer inteira: eram 690 municípios no Nordeste
de um total de 1.028, o que escondia os 211 do Norte. Somados, são quase 90%.

As linhas ficaram um pouco mais altas para caber o texto maior.
</commit_message>
<xml_diff>
--- a/docs/apresentacao.pptx
+++ b/docs/apresentacao.pptx
@@ -2120,11 +2120,11 @@
         <p:spPr>
           <a:xfrm>
             <a:off x="548640" y="1600200"/>
-            <a:ext cx="11064240" cy="841248"/>
+            <a:ext cx="11064240" cy="886968"/>
           </a:xfrm>
           <a:prstGeom prst="roundRect">
             <a:avLst>
-              <a:gd name="adj" fmla="val 6522"/>
+              <a:gd name="adj" fmla="val 6186"/>
             </a:avLst>
           </a:prstGeom>
           <a:solidFill>
@@ -2146,8 +2146,8 @@
         </p:nvSpPr>
         <p:spPr>
           <a:xfrm>
-            <a:off x="777240" y="1682496"/>
-            <a:ext cx="4572000" cy="676656"/>
+            <a:off x="777240" y="1691640"/>
+            <a:ext cx="4114800" cy="713232"/>
           </a:xfrm>
           <a:prstGeom prst="rect">
             <a:avLst/>
@@ -2163,7 +2163,7 @@
               <a:buNone/>
             </a:pPr>
             <a:r>
-              <a:rPr lang="en-US" sz="1350" b="1" dirty="0">
+              <a:rPr lang="en-US" sz="1300" b="1" dirty="0">
                 <a:solidFill>
                   <a:srgbClr val="1B6B5A"/>
                 </a:solidFill>
@@ -2173,7 +2173,7 @@
               </a:rPr>
               <a:t>Quais fatores mais impactam a alfabetização?</a:t>
             </a:r>
-            <a:endParaRPr lang="en-US" sz="1350" dirty="0"/>
+            <a:endParaRPr lang="en-US" sz="1300" dirty="0"/>
           </a:p>
         </p:txBody>
       </p:sp>
@@ -2185,8 +2185,8 @@
         </p:nvSpPr>
         <p:spPr>
           <a:xfrm>
-            <a:off x="5577840" y="1682496"/>
-            <a:ext cx="5852160" cy="676656"/>
+            <a:off x="5120640" y="1691640"/>
+            <a:ext cx="6309360" cy="713232"/>
           </a:xfrm>
           <a:prstGeom prst="rect">
             <a:avLst/>
@@ -2202,7 +2202,7 @@
               <a:buNone/>
             </a:pPr>
             <a:r>
-              <a:rPr lang="en-US" sz="1300" dirty="0">
+              <a:rPr lang="en-US" sz="1250" dirty="0">
                 <a:solidFill>
                   <a:srgbClr val="1A2B28"/>
                 </a:solidFill>
@@ -2210,9 +2210,9 @@
                 <a:ea typeface="Calibri" pitchFamily="34" charset="-122"/>
                 <a:cs typeface="Calibri" pitchFamily="34" charset="-120"/>
               </a:rPr>
-              <a:t>A história do município, com o dobro do peso da segunda variável</a:t>
-            </a:r>
-            <a:endParaRPr lang="en-US" sz="1300" dirty="0"/>
+              <a:t>Onde a criança estuda. O desempenho do município no ano anterior é o fator mais forte.</a:t>
+            </a:r>
+            <a:endParaRPr lang="en-US" sz="1250" dirty="0"/>
           </a:p>
         </p:txBody>
       </p:sp>
@@ -2224,12 +2224,12 @@
         </p:nvSpPr>
         <p:spPr>
           <a:xfrm>
-            <a:off x="548640" y="2514600"/>
-            <a:ext cx="11064240" cy="841248"/>
+            <a:off x="548640" y="2560320"/>
+            <a:ext cx="11064240" cy="886968"/>
           </a:xfrm>
           <a:prstGeom prst="roundRect">
             <a:avLst>
-              <a:gd name="adj" fmla="val 6522"/>
+              <a:gd name="adj" fmla="val 6186"/>
             </a:avLst>
           </a:prstGeom>
           <a:solidFill>
@@ -2251,8 +2251,8 @@
         </p:nvSpPr>
         <p:spPr>
           <a:xfrm>
-            <a:off x="777240" y="2596896"/>
-            <a:ext cx="4572000" cy="676656"/>
+            <a:off x="777240" y="2651760"/>
+            <a:ext cx="4114800" cy="713232"/>
           </a:xfrm>
           <a:prstGeom prst="rect">
             <a:avLst/>
@@ -2268,7 +2268,7 @@
               <a:buNone/>
             </a:pPr>
             <a:r>
-              <a:rPr lang="en-US" sz="1350" b="1" dirty="0">
+              <a:rPr lang="en-US" sz="1300" b="1" dirty="0">
                 <a:solidFill>
                   <a:srgbClr val="1B6B5A"/>
                 </a:solidFill>
@@ -2278,7 +2278,7 @@
               </a:rPr>
               <a:t>Quais variáveis influenciam mais o modelo?</a:t>
             </a:r>
-            <a:endParaRPr lang="en-US" sz="1350" dirty="0"/>
+            <a:endParaRPr lang="en-US" sz="1300" dirty="0"/>
           </a:p>
         </p:txBody>
       </p:sp>
@@ -2290,8 +2290,8 @@
         </p:nvSpPr>
         <p:spPr>
           <a:xfrm>
-            <a:off x="5577840" y="2596896"/>
-            <a:ext cx="5852160" cy="676656"/>
+            <a:off x="5120640" y="2651760"/>
+            <a:ext cx="6309360" cy="713232"/>
           </a:xfrm>
           <a:prstGeom prst="rect">
             <a:avLst/>
@@ -2307,7 +2307,7 @@
               <a:buNone/>
             </a:pPr>
             <a:r>
-              <a:rPr lang="en-US" sz="1300" dirty="0">
+              <a:rPr lang="en-US" sz="1250" dirty="0">
                 <a:solidFill>
                   <a:srgbClr val="1A2B28"/>
                 </a:solidFill>
@@ -2315,9 +2315,9 @@
                 <a:ea typeface="Calibri" pitchFamily="34" charset="-122"/>
                 <a:cs typeface="Calibri" pitchFamily="34" charset="-120"/>
               </a:rPr>
-              <a:t>Taxa histórica, UF e meta municipal; as cinco primeiras são territoriais</a:t>
-            </a:r>
-            <a:endParaRPr lang="en-US" sz="1300" dirty="0"/>
+              <a:t>As cinco maiores são todas de território. O que descreve o aluno quase não pesa.</a:t>
+            </a:r>
+            <a:endParaRPr lang="en-US" sz="1250" dirty="0"/>
           </a:p>
         </p:txBody>
       </p:sp>
@@ -2329,12 +2329,12 @@
         </p:nvSpPr>
         <p:spPr>
           <a:xfrm>
-            <a:off x="548640" y="3429000"/>
-            <a:ext cx="11064240" cy="841248"/>
+            <a:off x="548640" y="3520440"/>
+            <a:ext cx="11064240" cy="886968"/>
           </a:xfrm>
           <a:prstGeom prst="roundRect">
             <a:avLst>
-              <a:gd name="adj" fmla="val 6522"/>
+              <a:gd name="adj" fmla="val 6186"/>
             </a:avLst>
           </a:prstGeom>
           <a:solidFill>
@@ -2356,8 +2356,8 @@
         </p:nvSpPr>
         <p:spPr>
           <a:xfrm>
-            <a:off x="777240" y="3511296"/>
-            <a:ext cx="4572000" cy="676656"/>
+            <a:off x="777240" y="3611880"/>
+            <a:ext cx="4114800" cy="713232"/>
           </a:xfrm>
           <a:prstGeom prst="rect">
             <a:avLst/>
@@ -2373,7 +2373,7 @@
               <a:buNone/>
             </a:pPr>
             <a:r>
-              <a:rPr lang="en-US" sz="1350" b="1" dirty="0">
+              <a:rPr lang="en-US" sz="1300" b="1" dirty="0">
                 <a:solidFill>
                   <a:srgbClr val="1B6B5A"/>
                 </a:solidFill>
@@ -2383,7 +2383,7 @@
               </a:rPr>
               <a:t>Quais municípios apresentam maior risco?</a:t>
             </a:r>
-            <a:endParaRPr lang="en-US" sz="1350" dirty="0"/>
+            <a:endParaRPr lang="en-US" sz="1300" dirty="0"/>
           </a:p>
         </p:txBody>
       </p:sp>
@@ -2395,8 +2395,8 @@
         </p:nvSpPr>
         <p:spPr>
           <a:xfrm>
-            <a:off x="5577840" y="3511296"/>
-            <a:ext cx="5852160" cy="676656"/>
+            <a:off x="5120640" y="3611880"/>
+            <a:ext cx="6309360" cy="713232"/>
           </a:xfrm>
           <a:prstGeom prst="rect">
             <a:avLst/>
@@ -2412,7 +2412,7 @@
               <a:buNone/>
             </a:pPr>
             <a:r>
-              <a:rPr lang="en-US" sz="1300" dirty="0">
+              <a:rPr lang="en-US" sz="1250" dirty="0">
                 <a:solidFill>
                   <a:srgbClr val="1A2B28"/>
                 </a:solidFill>
@@ -2420,9 +2420,9 @@
                 <a:ea typeface="Calibri" pitchFamily="34" charset="-122"/>
                 <a:cs typeface="Calibri" pitchFamily="34" charset="-120"/>
               </a:rPr>
-              <a:t>1.028 no quinto mais crítico, 690 deles no Nordeste</a:t>
-            </a:r>
-            <a:endParaRPr lang="en-US" sz="1300" dirty="0"/>
+              <a:t>Os 1.028 com a menor taxa prevista. Quase 90% ficam no Nordeste e no Norte.</a:t>
+            </a:r>
+            <a:endParaRPr lang="en-US" sz="1250" dirty="0"/>
           </a:p>
         </p:txBody>
       </p:sp>
@@ -2434,12 +2434,12 @@
         </p:nvSpPr>
         <p:spPr>
           <a:xfrm>
-            <a:off x="548640" y="4343400"/>
-            <a:ext cx="11064240" cy="841248"/>
+            <a:off x="548640" y="4480560"/>
+            <a:ext cx="11064240" cy="886968"/>
           </a:xfrm>
           <a:prstGeom prst="roundRect">
             <a:avLst>
-              <a:gd name="adj" fmla="val 6522"/>
+              <a:gd name="adj" fmla="val 6186"/>
             </a:avLst>
           </a:prstGeom>
           <a:solidFill>
@@ -2461,8 +2461,8 @@
         </p:nvSpPr>
         <p:spPr>
           <a:xfrm>
-            <a:off x="777240" y="4425696"/>
-            <a:ext cx="4572000" cy="676656"/>
+            <a:off x="777240" y="4572000"/>
+            <a:ext cx="4114800" cy="713232"/>
           </a:xfrm>
           <a:prstGeom prst="rect">
             <a:avLst/>
@@ -2478,7 +2478,7 @@
               <a:buNone/>
             </a:pPr>
             <a:r>
-              <a:rPr lang="en-US" sz="1350" b="1" dirty="0">
+              <a:rPr lang="en-US" sz="1300" b="1" dirty="0">
                 <a:solidFill>
                   <a:srgbClr val="1B6B5A"/>
                 </a:solidFill>
@@ -2488,7 +2488,7 @@
               </a:rPr>
               <a:t>Quais regiões têm padrões semelhantes?</a:t>
             </a:r>
-            <a:endParaRPr lang="en-US" sz="1350" dirty="0"/>
+            <a:endParaRPr lang="en-US" sz="1300" dirty="0"/>
           </a:p>
         </p:txBody>
       </p:sp>
@@ -2500,8 +2500,8 @@
         </p:nvSpPr>
         <p:spPr>
           <a:xfrm>
-            <a:off x="5577840" y="4425696"/>
-            <a:ext cx="5852160" cy="676656"/>
+            <a:off x="5120640" y="4572000"/>
+            <a:ext cx="6309360" cy="713232"/>
           </a:xfrm>
           <a:prstGeom prst="rect">
             <a:avLst/>
@@ -2517,7 +2517,7 @@
               <a:buNone/>
             </a:pPr>
             <a:r>
-              <a:rPr lang="en-US" sz="1300" dirty="0">
+              <a:rPr lang="en-US" sz="1250" dirty="0">
                 <a:solidFill>
                   <a:srgbClr val="1A2B28"/>
                 </a:solidFill>
@@ -2525,9 +2525,9 @@
                 <a:ea typeface="Calibri" pitchFamily="34" charset="-122"/>
                 <a:cs typeface="Calibri" pitchFamily="34" charset="-120"/>
               </a:rPr>
-              <a:t>Quatro perfis; dois com a mesma renda e 27 pontos de diferença</a:t>
-            </a:r>
-            <a:endParaRPr lang="en-US" sz="1300" dirty="0"/>
+              <a:t>Os municípios formam quatro perfis. Dois têm a mesma renda e taxas de 47% e 74%.</a:t>
+            </a:r>
+            <a:endParaRPr lang="en-US" sz="1250" dirty="0"/>
           </a:p>
         </p:txBody>
       </p:sp>
@@ -2539,12 +2539,12 @@
         </p:nvSpPr>
         <p:spPr>
           <a:xfrm>
-            <a:off x="548640" y="5257800"/>
-            <a:ext cx="11064240" cy="841248"/>
+            <a:off x="548640" y="5440680"/>
+            <a:ext cx="11064240" cy="886968"/>
           </a:xfrm>
           <a:prstGeom prst="roundRect">
             <a:avLst>
-              <a:gd name="adj" fmla="val 6522"/>
+              <a:gd name="adj" fmla="val 6186"/>
             </a:avLst>
           </a:prstGeom>
           <a:solidFill>
@@ -2566,8 +2566,8 @@
         </p:nvSpPr>
         <p:spPr>
           <a:xfrm>
-            <a:off x="777240" y="5340096"/>
-            <a:ext cx="4572000" cy="676656"/>
+            <a:off x="777240" y="5532120"/>
+            <a:ext cx="4114800" cy="713232"/>
           </a:xfrm>
           <a:prstGeom prst="rect">
             <a:avLst/>
@@ -2583,7 +2583,7 @@
               <a:buNone/>
             </a:pPr>
             <a:r>
-              <a:rPr lang="en-US" sz="1350" b="1" dirty="0">
+              <a:rPr lang="en-US" sz="1300" b="1" dirty="0">
                 <a:solidFill>
                   <a:srgbClr val="1B6B5A"/>
                 </a:solidFill>
@@ -2593,7 +2593,7 @@
               </a:rPr>
               <a:t>Como prever quem não atinge a meta de 2030?</a:t>
             </a:r>
-            <a:endParaRPr lang="en-US" sz="1350" dirty="0"/>
+            <a:endParaRPr lang="en-US" sz="1300" dirty="0"/>
           </a:p>
         </p:txBody>
       </p:sp>
@@ -2605,8 +2605,8 @@
         </p:nvSpPr>
         <p:spPr>
           <a:xfrm>
-            <a:off x="5577840" y="5340096"/>
-            <a:ext cx="5852160" cy="676656"/>
+            <a:off x="5120640" y="5532120"/>
+            <a:ext cx="6309360" cy="713232"/>
           </a:xfrm>
           <a:prstGeom prst="rect">
             <a:avLst/>
@@ -2622,7 +2622,7 @@
               <a:buNone/>
             </a:pPr>
             <a:r>
-              <a:rPr lang="en-US" sz="1300" dirty="0">
+              <a:rPr lang="en-US" sz="1250" dirty="0">
                 <a:solidFill>
                   <a:srgbClr val="1A2B28"/>
                 </a:solidFill>
@@ -2630,9 +2630,9 @@
                 <a:ea typeface="Calibri" pitchFamily="34" charset="-122"/>
                 <a:cs typeface="Calibri" pitchFamily="34" charset="-120"/>
               </a:rPr>
-              <a:t>O país avança 2,68 p.p./ano e a meta pede 2,76</a:t>
-            </a:r>
-            <a:endParaRPr lang="en-US" sz="1300" dirty="0"/>
+              <a:t>Comparando o avanço de cada ano com o necessário. O país sobe 2,68 pontos ao ano e a meta pede 2,76.</a:t>
+            </a:r>
+            <a:endParaRPr lang="en-US" sz="1250" dirty="0"/>
           </a:p>
         </p:txBody>
       </p:sp>

</xml_diff>